<commit_message>
docs(presentation): align the demo-journey slide with the team's system demo
Slide 10 now previews the farmer journey the showcase video actually
shows (Zone 2 critical, FAO-56 advice, 90-minute run rejected, 5-minute
run sent and recorded, admin follow-up), using the demo's own screens
labelled as illustrative demo data. Script, notes and audit updated.

Co-Authored-By: Claude Opus 5.5 <noreply@anthropic.com>
Claude-Session: https://claude.ai/code/session_01GvJvi1Ve7TEpCm6qTovKDX
</commit_message>
<xml_diff>
--- a/presentation/AgroFlow_Showcase_Intro_2026.pptx
+++ b/presentation/AgroFlow_Showcase_Intro_2026.pptx
@@ -116,26 +116,26 @@
   <p:extLst>
     <p:ext uri="{521415D9-36F7-43E2-AB2F-B90AF26B5E84}">
       <p14:sectionLst xmlns:p14="http://schemas.microsoft.com/office/powerpoint/2010/main">
-        <p14:section name="Introduction" id="{e43e10a0-024a-1ba4-8037-5a20bd71dc39}">
+        <p14:section name="Introduction" id="{d47618c5-75b7-bc52-9bf3-4ddd971b7dbb}">
           <p14:sldIdLst>
             <p14:sldId id="256"/>
             <p14:sldId id="257"/>
             <p14:sldId id="258"/>
           </p14:sldIdLst>
         </p14:section>
-        <p14:section name="Solution" id="{cce84bd1-f5d0-22c8-1069-7a9c0a008912}">
+        <p14:section name="Solution" id="{7fed257a-17b0-8f65-2743-5642d76d183c}">
           <p14:sldIdLst>
             <p14:sldId id="259"/>
             <p14:sldId id="260"/>
           </p14:sldIdLst>
         </p14:section>
-        <p14:section name="Design" id="{26524c7c-b82a-0f28-f1fd-c695279c9080}">
+        <p14:section name="Design" id="{5d000f03-05d8-d616-87a5-2e4d333d87f7}">
           <p14:sldIdLst>
             <p14:sldId id="261"/>
             <p14:sldId id="262"/>
           </p14:sldIdLst>
         </p14:section>
-        <p14:section name="Implementation" id="{06cc9517-4862-853c-b504-90a7db7f2fdf}">
+        <p14:section name="Implementation" id="{1c8e8a1f-6f82-37ed-6671-bbdeef00cc12}">
           <p14:sldIdLst>
             <p14:sldId id="263"/>
             <p14:sldId id="264"/>
@@ -638,12 +638,10 @@
             <a:r>
               <a:rPr lang="en-US" dirty="0"/>
               <a:t>SPEAKER 4 — Olwethu. ~45 s.
-Our demo follows one end-to-end journey.
-An administrator registers a farm, choosing the farmer, a map pin and a supported crop. They register a kit and receive a one-time code. The board is enrolled with that code and comes online, and we run the zone's advice.
-Then we switch to the farmer's app for the forecast, a water report and the Telegram message, and finish on the activity log.
-We'll also show a validation check: if the farm name is cleared before saving, the wizard returns to the step that is wrong.
+Our system demo follows one farmer's day. They open AgroFlow, and Drip, the app's helper, points them to Zone 2. Its soil moisture has dropped below its start level, so the zone is critical, and the FAO-56 advice says to water now for about five minutes.
+The farmer switches the zone to manual and starts a run. When they type ninety minutes, the app stops them, because a run must be between one and sixty minutes. They correct it to five. The command reaches the kit, the pump runs, and the run appears in their history. Finally, an administrator follows up the alert.
 Now, let's see AgroFlow in action.
-Source: docs/presentation-runbook.md (the team's demo script, steps 1–7); validation: apps/web/admin/src/app/interactions.ts findFirstProblem (jumps back to the failing step). If the demo instead shows the farmer starting a manual run: the app rejects durations outside 1–60 minutes ('Enter a duration between 1 and 60 minutes.') — but the firmware stops every run at 5 minutes, so choose 5 minutes or less.</a:t>
+Source: the team's system demo (showcase/narration.md, showcase/system-audit.md, showcase/assets/screens/*). Screens are the real, unmodified app answering with clearly labelled illustrative demo data (showcase/capture/demo-data.mjs), approved by the team per showcase/system-audit.md. Validation: apps/mobile/src/app/zone/[id].tsx handleStartManualRun ('Enter a duration between 1 and 60 minutes.'). The demo uses 5 minutes, which fits the firmware's 5-minute safety cap.</a:t>
             </a:r>
             <a:endParaRPr lang="en-US" dirty="0"/>
           </a:p>
@@ -2876,7 +2874,7 @@
                   <a:srgbClr val="0F2A36"/>
                 </a:solidFill>
               </a:rPr>
-              <a:t>Admin signs in</a:t>
+              <a:t>Farmer opens AgroFlow</a:t>
             </a:r>
             <a:endParaRPr lang="en-US" sz="1300" dirty="0"/>
           </a:p>
@@ -2891,7 +2889,7 @@
         <p:spPr>
           <a:xfrm>
             <a:off x="502920" y="2157984"/>
-            <a:ext cx="1481328" cy="640080"/>
+            <a:ext cx="1481328" cy="548640"/>
           </a:xfrm>
           <a:prstGeom prst="rect">
             <a:avLst/>
@@ -2912,7 +2910,7 @@
                   <a:srgbClr val="5B6B73"/>
                 </a:solidFill>
               </a:rPr>
-              <a:t>Home shows what needs attention</a:t>
+              <a:t>Drip points to today's one action</a:t>
             </a:r>
             <a:endParaRPr lang="en-US" sz="1100" dirty="0"/>
           </a:p>
@@ -2927,6 +2925,144 @@
         <p:spPr>
           <a:xfrm>
             <a:off x="2660904" y="1234440"/>
+            <a:ext cx="384048" cy="384048"/>
+          </a:xfrm>
+          <a:prstGeom prst="ellipse">
+            <a:avLst/>
+          </a:prstGeom>
+          <a:solidFill>
+            <a:srgbClr val="C98A00"/>
+          </a:solidFill>
+          <a:ln>
+            <a:solidFill>
+              <a:srgbClr val="C98A00"/>
+            </a:solidFill>
+          </a:ln>
+        </p:spPr>
+        <p:txBody>
+          <a:bodyPr wrap="square" lIns="0" tIns="0" rIns="0" bIns="0" rtlCol="0" anchor="ctr"/>
+          <a:lstStyle/>
+          <a:p>
+            <a:pPr algn="ctr" indent="0" marL="0">
+              <a:buNone/>
+            </a:pPr>
+            <a:r>
+              <a:rPr lang="en-US" sz="1400" b="1" dirty="0">
+                <a:solidFill>
+                  <a:srgbClr val="FFFFFF"/>
+                </a:solidFill>
+              </a:rPr>
+              <a:t>2</a:t>
+            </a:r>
+            <a:endParaRPr lang="en-US" sz="1400" dirty="0"/>
+          </a:p>
+        </p:txBody>
+      </p:sp>
+      <p:sp>
+        <p:nvSpPr>
+          <p:cNvPr id="9" name="Shape 7"/>
+          <p:cNvSpPr/>
+          <p:nvPr/>
+        </p:nvSpPr>
+        <p:spPr>
+          <a:xfrm>
+            <a:off x="3099816" y="1426464"/>
+            <a:ext cx="1115568" cy="914"/>
+          </a:xfrm>
+          <a:prstGeom prst="line">
+            <a:avLst/>
+          </a:prstGeom>
+          <a:noFill/>
+          <a:ln w="19050">
+            <a:solidFill>
+              <a:srgbClr val="C9D6D9"/>
+            </a:solidFill>
+            <a:prstDash val="solid"/>
+            <a:tailEnd type="triangle"/>
+          </a:ln>
+        </p:spPr>
+      </p:sp>
+      <p:sp>
+        <p:nvSpPr>
+          <p:cNvPr id="10" name="Text 8"/>
+          <p:cNvSpPr txBox="1"/>
+          <p:nvPr/>
+        </p:nvSpPr>
+        <p:spPr>
+          <a:xfrm>
+            <a:off x="2112264" y="1719072"/>
+            <a:ext cx="1481328" cy="457200"/>
+          </a:xfrm>
+          <a:prstGeom prst="rect">
+            <a:avLst/>
+          </a:prstGeom>
+          <a:noFill/>
+          <a:ln/>
+        </p:spPr>
+        <p:txBody>
+          <a:bodyPr wrap="square" lIns="0" tIns="0" rIns="0" bIns="0" rtlCol="0" anchor="t"/>
+          <a:lstStyle/>
+          <a:p>
+            <a:pPr algn="ctr" indent="0" marL="0">
+              <a:buNone/>
+            </a:pPr>
+            <a:r>
+              <a:rPr lang="en-US" sz="1300" b="1" dirty="0">
+                <a:solidFill>
+                  <a:srgbClr val="0F2A36"/>
+                </a:solidFill>
+              </a:rPr>
+              <a:t>Zone 2 is critical</a:t>
+            </a:r>
+            <a:endParaRPr lang="en-US" sz="1300" dirty="0"/>
+          </a:p>
+        </p:txBody>
+      </p:sp>
+      <p:sp>
+        <p:nvSpPr>
+          <p:cNvPr id="11" name="Text 9"/>
+          <p:cNvSpPr txBox="1"/>
+          <p:nvPr/>
+        </p:nvSpPr>
+        <p:spPr>
+          <a:xfrm>
+            <a:off x="2112264" y="2157984"/>
+            <a:ext cx="1481328" cy="548640"/>
+          </a:xfrm>
+          <a:prstGeom prst="rect">
+            <a:avLst/>
+          </a:prstGeom>
+          <a:noFill/>
+          <a:ln/>
+        </p:spPr>
+        <p:txBody>
+          <a:bodyPr wrap="square" lIns="0" tIns="0" rIns="0" bIns="0" rtlCol="0" anchor="t"/>
+          <a:lstStyle/>
+          <a:p>
+            <a:pPr algn="ctr" indent="0" marL="0">
+              <a:buNone/>
+            </a:pPr>
+            <a:r>
+              <a:rPr lang="en-US" sz="1100" dirty="0">
+                <a:solidFill>
+                  <a:srgbClr val="5B6B73"/>
+                </a:solidFill>
+              </a:rPr>
+              <a:t>Soil moisture below its start level</a:t>
+            </a:r>
+            <a:endParaRPr lang="en-US" sz="1100" dirty="0"/>
+          </a:p>
+        </p:txBody>
+      </p:sp>
+      <p:sp>
+        <p:nvSpPr>
+          <p:cNvPr id="12" name="Step 3"/>
+          <p:cNvSpPr txBox="1"/>
+          <p:nvPr/>
+        </p:nvSpPr>
+        <p:spPr>
+          <a:xfrm>
+            <a:off x="4270248" y="1234440"/>
             <a:ext cx="384048" cy="384048"/>
           </a:xfrm>
           <a:prstGeom prst="ellipse">
@@ -2954,7 +3090,7 @@
                   <a:srgbClr val="FFFFFF"/>
                 </a:solidFill>
               </a:rPr>
-              <a:t>2</a:t>
+              <a:t>3</a:t>
             </a:r>
             <a:endParaRPr lang="en-US" sz="1400" dirty="0"/>
           </a:p>
@@ -2962,13 +3098,13 @@
       </p:sp>
       <p:sp>
         <p:nvSpPr>
-          <p:cNvPr id="9" name="Shape 7"/>
+          <p:cNvPr id="13" name="Shape 11"/>
           <p:cNvSpPr/>
           <p:nvPr/>
         </p:nvSpPr>
         <p:spPr>
           <a:xfrm>
-            <a:off x="3099816" y="1426464"/>
+            <a:off x="4709160" y="1426464"/>
             <a:ext cx="1115568" cy="914"/>
           </a:xfrm>
           <a:prstGeom prst="line">
@@ -2986,13 +3122,13 @@
       </p:sp>
       <p:sp>
         <p:nvSpPr>
-          <p:cNvPr id="10" name="Text 8"/>
-          <p:cNvSpPr txBox="1"/>
-          <p:nvPr/>
-        </p:nvSpPr>
-        <p:spPr>
-          <a:xfrm>
-            <a:off x="2112264" y="1719072"/>
+          <p:cNvPr id="14" name="Text 12"/>
+          <p:cNvSpPr txBox="1"/>
+          <p:nvPr/>
+        </p:nvSpPr>
+        <p:spPr>
+          <a:xfrm>
+            <a:off x="3721608" y="1719072"/>
             <a:ext cx="1481328" cy="457200"/>
           </a:xfrm>
           <a:prstGeom prst="rect">
@@ -3014,7 +3150,7 @@
                   <a:srgbClr val="0F2A36"/>
                 </a:solidFill>
               </a:rPr>
-              <a:t>Registers a farm</a:t>
+              <a:t>Reads the advice</a:t>
             </a:r>
             <a:endParaRPr lang="en-US" sz="1300" dirty="0"/>
           </a:p>
@@ -3022,14 +3158,14 @@
       </p:sp>
       <p:sp>
         <p:nvSpPr>
-          <p:cNvPr id="11" name="Text 9"/>
-          <p:cNvSpPr txBox="1"/>
-          <p:nvPr/>
-        </p:nvSpPr>
-        <p:spPr>
-          <a:xfrm>
-            <a:off x="2112264" y="2157984"/>
-            <a:ext cx="1481328" cy="640080"/>
+          <p:cNvPr id="15" name="Text 13"/>
+          <p:cNvSpPr txBox="1"/>
+          <p:nvPr/>
+        </p:nvSpPr>
+        <p:spPr>
+          <a:xfrm>
+            <a:off x="3721608" y="2157984"/>
+            <a:ext cx="1481328" cy="548640"/>
           </a:xfrm>
           <a:prstGeom prst="rect">
             <a:avLst/>
@@ -3050,7 +3186,7 @@
                   <a:srgbClr val="5B6B73"/>
                 </a:solidFill>
               </a:rPr>
-              <a:t>Farmer, map pin, crop from the engine's list</a:t>
+              <a:t>FAO-56: water now, about 5 min</a:t>
             </a:r>
             <a:endParaRPr lang="en-US" sz="1100" dirty="0"/>
           </a:p>
@@ -3058,13 +3194,289 @@
       </p:sp>
       <p:sp>
         <p:nvSpPr>
-          <p:cNvPr id="12" name="Step 3"/>
-          <p:cNvSpPr txBox="1"/>
-          <p:nvPr/>
-        </p:nvSpPr>
-        <p:spPr>
-          <a:xfrm>
-            <a:off x="4270248" y="1234440"/>
+          <p:cNvPr id="16" name="Step 4"/>
+          <p:cNvSpPr txBox="1"/>
+          <p:nvPr/>
+        </p:nvSpPr>
+        <p:spPr>
+          <a:xfrm>
+            <a:off x="5879592" y="1234440"/>
+            <a:ext cx="384048" cy="384048"/>
+          </a:xfrm>
+          <a:prstGeom prst="ellipse">
+            <a:avLst/>
+          </a:prstGeom>
+          <a:solidFill>
+            <a:srgbClr val="1E88E5"/>
+          </a:solidFill>
+          <a:ln>
+            <a:solidFill>
+              <a:srgbClr val="1E88E5"/>
+            </a:solidFill>
+          </a:ln>
+        </p:spPr>
+        <p:txBody>
+          <a:bodyPr wrap="square" lIns="0" tIns="0" rIns="0" bIns="0" rtlCol="0" anchor="ctr"/>
+          <a:lstStyle/>
+          <a:p>
+            <a:pPr algn="ctr" indent="0" marL="0">
+              <a:buNone/>
+            </a:pPr>
+            <a:r>
+              <a:rPr lang="en-US" sz="1400" b="1" dirty="0">
+                <a:solidFill>
+                  <a:srgbClr val="FFFFFF"/>
+                </a:solidFill>
+              </a:rPr>
+              <a:t>4</a:t>
+            </a:r>
+            <a:endParaRPr lang="en-US" sz="1400" dirty="0"/>
+          </a:p>
+        </p:txBody>
+      </p:sp>
+      <p:sp>
+        <p:nvSpPr>
+          <p:cNvPr id="17" name="Shape 15"/>
+          <p:cNvSpPr/>
+          <p:nvPr/>
+        </p:nvSpPr>
+        <p:spPr>
+          <a:xfrm>
+            <a:off x="6318504" y="1426464"/>
+            <a:ext cx="1115568" cy="914"/>
+          </a:xfrm>
+          <a:prstGeom prst="line">
+            <a:avLst/>
+          </a:prstGeom>
+          <a:noFill/>
+          <a:ln w="19050">
+            <a:solidFill>
+              <a:srgbClr val="C9D6D9"/>
+            </a:solidFill>
+            <a:prstDash val="solid"/>
+            <a:tailEnd type="triangle"/>
+          </a:ln>
+        </p:spPr>
+      </p:sp>
+      <p:sp>
+        <p:nvSpPr>
+          <p:cNvPr id="18" name="Text 16"/>
+          <p:cNvSpPr txBox="1"/>
+          <p:nvPr/>
+        </p:nvSpPr>
+        <p:spPr>
+          <a:xfrm>
+            <a:off x="5330952" y="1719072"/>
+            <a:ext cx="1481328" cy="457200"/>
+          </a:xfrm>
+          <a:prstGeom prst="rect">
+            <a:avLst/>
+          </a:prstGeom>
+          <a:noFill/>
+          <a:ln/>
+        </p:spPr>
+        <p:txBody>
+          <a:bodyPr wrap="square" lIns="0" tIns="0" rIns="0" bIns="0" rtlCol="0" anchor="t"/>
+          <a:lstStyle/>
+          <a:p>
+            <a:pPr algn="ctr" indent="0" marL="0">
+              <a:buNone/>
+            </a:pPr>
+            <a:r>
+              <a:rPr lang="en-US" sz="1300" b="1" dirty="0">
+                <a:solidFill>
+                  <a:srgbClr val="0F2A36"/>
+                </a:solidFill>
+              </a:rPr>
+              <a:t>Starts a manual run</a:t>
+            </a:r>
+            <a:endParaRPr lang="en-US" sz="1300" dirty="0"/>
+          </a:p>
+        </p:txBody>
+      </p:sp>
+      <p:sp>
+        <p:nvSpPr>
+          <p:cNvPr id="19" name="Text 17"/>
+          <p:cNvSpPr txBox="1"/>
+          <p:nvPr/>
+        </p:nvSpPr>
+        <p:spPr>
+          <a:xfrm>
+            <a:off x="5330952" y="2157984"/>
+            <a:ext cx="1481328" cy="548640"/>
+          </a:xfrm>
+          <a:prstGeom prst="rect">
+            <a:avLst/>
+          </a:prstGeom>
+          <a:noFill/>
+          <a:ln/>
+        </p:spPr>
+        <p:txBody>
+          <a:bodyPr wrap="square" lIns="0" tIns="0" rIns="0" bIns="0" rtlCol="0" anchor="t"/>
+          <a:lstStyle/>
+          <a:p>
+            <a:pPr algn="ctr" indent="0" marL="0">
+              <a:buNone/>
+            </a:pPr>
+            <a:r>
+              <a:rPr lang="en-US" sz="1100" dirty="0">
+                <a:solidFill>
+                  <a:srgbClr val="5B6B73"/>
+                </a:solidFill>
+              </a:rPr>
+              <a:t>Switches the zone to Manual</a:t>
+            </a:r>
+            <a:endParaRPr lang="en-US" sz="1100" dirty="0"/>
+          </a:p>
+        </p:txBody>
+      </p:sp>
+      <p:sp>
+        <p:nvSpPr>
+          <p:cNvPr id="20" name="Step 5"/>
+          <p:cNvSpPr txBox="1"/>
+          <p:nvPr/>
+        </p:nvSpPr>
+        <p:spPr>
+          <a:xfrm>
+            <a:off x="7488936" y="1234440"/>
+            <a:ext cx="384048" cy="384048"/>
+          </a:xfrm>
+          <a:prstGeom prst="ellipse">
+            <a:avLst/>
+          </a:prstGeom>
+          <a:solidFill>
+            <a:srgbClr val="2F6B4B"/>
+          </a:solidFill>
+          <a:ln>
+            <a:solidFill>
+              <a:srgbClr val="2F6B4B"/>
+            </a:solidFill>
+          </a:ln>
+        </p:spPr>
+        <p:txBody>
+          <a:bodyPr wrap="square" lIns="0" tIns="0" rIns="0" bIns="0" rtlCol="0" anchor="ctr"/>
+          <a:lstStyle/>
+          <a:p>
+            <a:pPr algn="ctr" indent="0" marL="0">
+              <a:buNone/>
+            </a:pPr>
+            <a:r>
+              <a:rPr lang="en-US" sz="1400" b="1" dirty="0">
+                <a:solidFill>
+                  <a:srgbClr val="FFFFFF"/>
+                </a:solidFill>
+              </a:rPr>
+              <a:t>5</a:t>
+            </a:r>
+            <a:endParaRPr lang="en-US" sz="1400" dirty="0"/>
+          </a:p>
+        </p:txBody>
+      </p:sp>
+      <p:sp>
+        <p:nvSpPr>
+          <p:cNvPr id="21" name="Shape 19"/>
+          <p:cNvSpPr/>
+          <p:nvPr/>
+        </p:nvSpPr>
+        <p:spPr>
+          <a:xfrm>
+            <a:off x="7927848" y="1426464"/>
+            <a:ext cx="1115568" cy="914"/>
+          </a:xfrm>
+          <a:prstGeom prst="line">
+            <a:avLst/>
+          </a:prstGeom>
+          <a:noFill/>
+          <a:ln w="19050">
+            <a:solidFill>
+              <a:srgbClr val="C9D6D9"/>
+            </a:solidFill>
+            <a:prstDash val="solid"/>
+            <a:tailEnd type="triangle"/>
+          </a:ln>
+        </p:spPr>
+      </p:sp>
+      <p:sp>
+        <p:nvSpPr>
+          <p:cNvPr id="22" name="Text 20"/>
+          <p:cNvSpPr txBox="1"/>
+          <p:nvPr/>
+        </p:nvSpPr>
+        <p:spPr>
+          <a:xfrm>
+            <a:off x="6940296" y="1719072"/>
+            <a:ext cx="1481328" cy="457200"/>
+          </a:xfrm>
+          <a:prstGeom prst="rect">
+            <a:avLst/>
+          </a:prstGeom>
+          <a:noFill/>
+          <a:ln/>
+        </p:spPr>
+        <p:txBody>
+          <a:bodyPr wrap="square" lIns="0" tIns="0" rIns="0" bIns="0" rtlCol="0" anchor="t"/>
+          <a:lstStyle/>
+          <a:p>
+            <a:pPr algn="ctr" indent="0" marL="0">
+              <a:buNone/>
+            </a:pPr>
+            <a:r>
+              <a:rPr lang="en-US" sz="1300" b="1" dirty="0">
+                <a:solidFill>
+                  <a:srgbClr val="0F2A36"/>
+                </a:solidFill>
+              </a:rPr>
+              <a:t>Command reaches the kit</a:t>
+            </a:r>
+            <a:endParaRPr lang="en-US" sz="1300" dirty="0"/>
+          </a:p>
+        </p:txBody>
+      </p:sp>
+      <p:sp>
+        <p:nvSpPr>
+          <p:cNvPr id="23" name="Text 21"/>
+          <p:cNvSpPr txBox="1"/>
+          <p:nvPr/>
+        </p:nvSpPr>
+        <p:spPr>
+          <a:xfrm>
+            <a:off x="6940296" y="2157984"/>
+            <a:ext cx="1481328" cy="548640"/>
+          </a:xfrm>
+          <a:prstGeom prst="rect">
+            <a:avLst/>
+          </a:prstGeom>
+          <a:noFill/>
+          <a:ln/>
+        </p:spPr>
+        <p:txBody>
+          <a:bodyPr wrap="square" lIns="0" tIns="0" rIns="0" bIns="0" rtlCol="0" anchor="t"/>
+          <a:lstStyle/>
+          <a:p>
+            <a:pPr algn="ctr" indent="0" marL="0">
+              <a:buNone/>
+            </a:pPr>
+            <a:r>
+              <a:rPr lang="en-US" sz="1100" dirty="0">
+                <a:solidFill>
+                  <a:srgbClr val="5B6B73"/>
+                </a:solidFill>
+              </a:rPr>
+              <a:t>API → MQTT → ESP32 → pump</a:t>
+            </a:r>
+            <a:endParaRPr lang="en-US" sz="1100" dirty="0"/>
+          </a:p>
+        </p:txBody>
+      </p:sp>
+      <p:sp>
+        <p:nvSpPr>
+          <p:cNvPr id="24" name="Step 6"/>
+          <p:cNvSpPr txBox="1"/>
+          <p:nvPr/>
+        </p:nvSpPr>
+        <p:spPr>
+          <a:xfrm>
+            <a:off x="9098280" y="1234440"/>
             <a:ext cx="384048" cy="384048"/>
           </a:xfrm>
           <a:prstGeom prst="ellipse">
@@ -3092,7 +3504,7 @@
                   <a:srgbClr val="FFFFFF"/>
                 </a:solidFill>
               </a:rPr>
-              <a:t>3</a:t>
+              <a:t>6</a:t>
             </a:r>
             <a:endParaRPr lang="en-US" sz="1400" dirty="0"/>
           </a:p>
@@ -3100,13 +3512,13 @@
       </p:sp>
       <p:sp>
         <p:nvSpPr>
-          <p:cNvPr id="13" name="Shape 11"/>
+          <p:cNvPr id="25" name="Shape 23"/>
           <p:cNvSpPr/>
           <p:nvPr/>
         </p:nvSpPr>
         <p:spPr>
           <a:xfrm>
-            <a:off x="4709160" y="1426464"/>
+            <a:off x="9537192" y="1426464"/>
             <a:ext cx="1115568" cy="914"/>
           </a:xfrm>
           <a:prstGeom prst="line">
@@ -3124,420 +3536,6 @@
       </p:sp>
       <p:sp>
         <p:nvSpPr>
-          <p:cNvPr id="14" name="Text 12"/>
-          <p:cNvSpPr txBox="1"/>
-          <p:nvPr/>
-        </p:nvSpPr>
-        <p:spPr>
-          <a:xfrm>
-            <a:off x="3721608" y="1719072"/>
-            <a:ext cx="1481328" cy="457200"/>
-          </a:xfrm>
-          <a:prstGeom prst="rect">
-            <a:avLst/>
-          </a:prstGeom>
-          <a:noFill/>
-          <a:ln/>
-        </p:spPr>
-        <p:txBody>
-          <a:bodyPr wrap="square" lIns="0" tIns="0" rIns="0" bIns="0" rtlCol="0" anchor="t"/>
-          <a:lstStyle/>
-          <a:p>
-            <a:pPr algn="ctr" indent="0" marL="0">
-              <a:buNone/>
-            </a:pPr>
-            <a:r>
-              <a:rPr lang="en-US" sz="1300" b="1" dirty="0">
-                <a:solidFill>
-                  <a:srgbClr val="0F2A36"/>
-                </a:solidFill>
-              </a:rPr>
-              <a:t>Registers a kit</a:t>
-            </a:r>
-            <a:endParaRPr lang="en-US" sz="1300" dirty="0"/>
-          </a:p>
-        </p:txBody>
-      </p:sp>
-      <p:sp>
-        <p:nvSpPr>
-          <p:cNvPr id="15" name="Text 13"/>
-          <p:cNvSpPr txBox="1"/>
-          <p:nvPr/>
-        </p:nvSpPr>
-        <p:spPr>
-          <a:xfrm>
-            <a:off x="3721608" y="2157984"/>
-            <a:ext cx="1481328" cy="640080"/>
-          </a:xfrm>
-          <a:prstGeom prst="rect">
-            <a:avLst/>
-          </a:prstGeom>
-          <a:noFill/>
-          <a:ln/>
-        </p:spPr>
-        <p:txBody>
-          <a:bodyPr wrap="square" lIns="0" tIns="0" rIns="0" bIns="0" rtlCol="0" anchor="t"/>
-          <a:lstStyle/>
-          <a:p>
-            <a:pPr algn="ctr" indent="0" marL="0">
-              <a:buNone/>
-            </a:pPr>
-            <a:r>
-              <a:rPr lang="en-US" sz="1100" dirty="0">
-                <a:solidFill>
-                  <a:srgbClr val="5B6B73"/>
-                </a:solidFill>
-              </a:rPr>
-              <a:t>One-time enrolment code</a:t>
-            </a:r>
-            <a:endParaRPr lang="en-US" sz="1100" dirty="0"/>
-          </a:p>
-        </p:txBody>
-      </p:sp>
-      <p:sp>
-        <p:nvSpPr>
-          <p:cNvPr id="16" name="Step 4"/>
-          <p:cNvSpPr txBox="1"/>
-          <p:nvPr/>
-        </p:nvSpPr>
-        <p:spPr>
-          <a:xfrm>
-            <a:off x="5879592" y="1234440"/>
-            <a:ext cx="384048" cy="384048"/>
-          </a:xfrm>
-          <a:prstGeom prst="ellipse">
-            <a:avLst/>
-          </a:prstGeom>
-          <a:solidFill>
-            <a:srgbClr val="2F6B4B"/>
-          </a:solidFill>
-          <a:ln>
-            <a:solidFill>
-              <a:srgbClr val="2F6B4B"/>
-            </a:solidFill>
-          </a:ln>
-        </p:spPr>
-        <p:txBody>
-          <a:bodyPr wrap="square" lIns="0" tIns="0" rIns="0" bIns="0" rtlCol="0" anchor="ctr"/>
-          <a:lstStyle/>
-          <a:p>
-            <a:pPr algn="ctr" indent="0" marL="0">
-              <a:buNone/>
-            </a:pPr>
-            <a:r>
-              <a:rPr lang="en-US" sz="1400" b="1" dirty="0">
-                <a:solidFill>
-                  <a:srgbClr val="FFFFFF"/>
-                </a:solidFill>
-              </a:rPr>
-              <a:t>4</a:t>
-            </a:r>
-            <a:endParaRPr lang="en-US" sz="1400" dirty="0"/>
-          </a:p>
-        </p:txBody>
-      </p:sp>
-      <p:sp>
-        <p:nvSpPr>
-          <p:cNvPr id="17" name="Shape 15"/>
-          <p:cNvSpPr/>
-          <p:nvPr/>
-        </p:nvSpPr>
-        <p:spPr>
-          <a:xfrm>
-            <a:off x="6318504" y="1426464"/>
-            <a:ext cx="1115568" cy="914"/>
-          </a:xfrm>
-          <a:prstGeom prst="line">
-            <a:avLst/>
-          </a:prstGeom>
-          <a:noFill/>
-          <a:ln w="19050">
-            <a:solidFill>
-              <a:srgbClr val="C9D6D9"/>
-            </a:solidFill>
-            <a:prstDash val="solid"/>
-            <a:tailEnd type="triangle"/>
-          </a:ln>
-        </p:spPr>
-      </p:sp>
-      <p:sp>
-        <p:nvSpPr>
-          <p:cNvPr id="18" name="Text 16"/>
-          <p:cNvSpPr txBox="1"/>
-          <p:nvPr/>
-        </p:nvSpPr>
-        <p:spPr>
-          <a:xfrm>
-            <a:off x="5330952" y="1719072"/>
-            <a:ext cx="1481328" cy="457200"/>
-          </a:xfrm>
-          <a:prstGeom prst="rect">
-            <a:avLst/>
-          </a:prstGeom>
-          <a:noFill/>
-          <a:ln/>
-        </p:spPr>
-        <p:txBody>
-          <a:bodyPr wrap="square" lIns="0" tIns="0" rIns="0" bIns="0" rtlCol="0" anchor="t"/>
-          <a:lstStyle/>
-          <a:p>
-            <a:pPr algn="ctr" indent="0" marL="0">
-              <a:buNone/>
-            </a:pPr>
-            <a:r>
-              <a:rPr lang="en-US" sz="1300" b="1" dirty="0">
-                <a:solidFill>
-                  <a:srgbClr val="0F2A36"/>
-                </a:solidFill>
-              </a:rPr>
-              <a:t>Kit is enrolled on site</a:t>
-            </a:r>
-            <a:endParaRPr lang="en-US" sz="1300" dirty="0"/>
-          </a:p>
-        </p:txBody>
-      </p:sp>
-      <p:sp>
-        <p:nvSpPr>
-          <p:cNvPr id="19" name="Text 17"/>
-          <p:cNvSpPr txBox="1"/>
-          <p:nvPr/>
-        </p:nvSpPr>
-        <p:spPr>
-          <a:xfrm>
-            <a:off x="5330952" y="2157984"/>
-            <a:ext cx="1481328" cy="640080"/>
-          </a:xfrm>
-          <a:prstGeom prst="rect">
-            <a:avLst/>
-          </a:prstGeom>
-          <a:noFill/>
-          <a:ln/>
-        </p:spPr>
-        <p:txBody>
-          <a:bodyPr wrap="square" lIns="0" tIns="0" rIns="0" bIns="0" rtlCol="0" anchor="t"/>
-          <a:lstStyle/>
-          <a:p>
-            <a:pPr algn="ctr" indent="0" marL="0">
-              <a:buNone/>
-            </a:pPr>
-            <a:r>
-              <a:rPr lang="en-US" sz="1100" dirty="0">
-                <a:solidFill>
-                  <a:srgbClr val="5B6B73"/>
-                </a:solidFill>
-              </a:rPr>
-              <a:t>Setup Wi-Fi + code, board joins</a:t>
-            </a:r>
-            <a:endParaRPr lang="en-US" sz="1100" dirty="0"/>
-          </a:p>
-        </p:txBody>
-      </p:sp>
-      <p:sp>
-        <p:nvSpPr>
-          <p:cNvPr id="20" name="Step 5"/>
-          <p:cNvSpPr txBox="1"/>
-          <p:nvPr/>
-        </p:nvSpPr>
-        <p:spPr>
-          <a:xfrm>
-            <a:off x="7488936" y="1234440"/>
-            <a:ext cx="384048" cy="384048"/>
-          </a:xfrm>
-          <a:prstGeom prst="ellipse">
-            <a:avLst/>
-          </a:prstGeom>
-          <a:solidFill>
-            <a:srgbClr val="2F6B4B"/>
-          </a:solidFill>
-          <a:ln>
-            <a:solidFill>
-              <a:srgbClr val="2F6B4B"/>
-            </a:solidFill>
-          </a:ln>
-        </p:spPr>
-        <p:txBody>
-          <a:bodyPr wrap="square" lIns="0" tIns="0" rIns="0" bIns="0" rtlCol="0" anchor="ctr"/>
-          <a:lstStyle/>
-          <a:p>
-            <a:pPr algn="ctr" indent="0" marL="0">
-              <a:buNone/>
-            </a:pPr>
-            <a:r>
-              <a:rPr lang="en-US" sz="1400" b="1" dirty="0">
-                <a:solidFill>
-                  <a:srgbClr val="FFFFFF"/>
-                </a:solidFill>
-              </a:rPr>
-              <a:t>5</a:t>
-            </a:r>
-            <a:endParaRPr lang="en-US" sz="1400" dirty="0"/>
-          </a:p>
-        </p:txBody>
-      </p:sp>
-      <p:sp>
-        <p:nvSpPr>
-          <p:cNvPr id="21" name="Shape 19"/>
-          <p:cNvSpPr/>
-          <p:nvPr/>
-        </p:nvSpPr>
-        <p:spPr>
-          <a:xfrm>
-            <a:off x="7927848" y="1426464"/>
-            <a:ext cx="1115568" cy="914"/>
-          </a:xfrm>
-          <a:prstGeom prst="line">
-            <a:avLst/>
-          </a:prstGeom>
-          <a:noFill/>
-          <a:ln w="19050">
-            <a:solidFill>
-              <a:srgbClr val="C9D6D9"/>
-            </a:solidFill>
-            <a:prstDash val="solid"/>
-            <a:tailEnd type="triangle"/>
-          </a:ln>
-        </p:spPr>
-      </p:sp>
-      <p:sp>
-        <p:nvSpPr>
-          <p:cNvPr id="22" name="Text 20"/>
-          <p:cNvSpPr txBox="1"/>
-          <p:nvPr/>
-        </p:nvSpPr>
-        <p:spPr>
-          <a:xfrm>
-            <a:off x="6940296" y="1719072"/>
-            <a:ext cx="1481328" cy="457200"/>
-          </a:xfrm>
-          <a:prstGeom prst="rect">
-            <a:avLst/>
-          </a:prstGeom>
-          <a:noFill/>
-          <a:ln/>
-        </p:spPr>
-        <p:txBody>
-          <a:bodyPr wrap="square" lIns="0" tIns="0" rIns="0" bIns="0" rtlCol="0" anchor="t"/>
-          <a:lstStyle/>
-          <a:p>
-            <a:pPr algn="ctr" indent="0" marL="0">
-              <a:buNone/>
-            </a:pPr>
-            <a:r>
-              <a:rPr lang="en-US" sz="1300" b="1" dirty="0">
-                <a:solidFill>
-                  <a:srgbClr val="0F2A36"/>
-                </a:solidFill>
-              </a:rPr>
-              <a:t>Kit comes online</a:t>
-            </a:r>
-            <a:endParaRPr lang="en-US" sz="1300" dirty="0"/>
-          </a:p>
-        </p:txBody>
-      </p:sp>
-      <p:sp>
-        <p:nvSpPr>
-          <p:cNvPr id="23" name="Text 21"/>
-          <p:cNvSpPr txBox="1"/>
-          <p:nvPr/>
-        </p:nvSpPr>
-        <p:spPr>
-          <a:xfrm>
-            <a:off x="6940296" y="2157984"/>
-            <a:ext cx="1481328" cy="640080"/>
-          </a:xfrm>
-          <a:prstGeom prst="rect">
-            <a:avLst/>
-          </a:prstGeom>
-          <a:noFill/>
-          <a:ln/>
-        </p:spPr>
-        <p:txBody>
-          <a:bodyPr wrap="square" lIns="0" tIns="0" rIns="0" bIns="0" rtlCol="0" anchor="t"/>
-          <a:lstStyle/>
-          <a:p>
-            <a:pPr algn="ctr" indent="0" marL="0">
-              <a:buNone/>
-            </a:pPr>
-            <a:r>
-              <a:rPr lang="en-US" sz="1100" dirty="0">
-                <a:solidFill>
-                  <a:srgbClr val="5B6B73"/>
-                </a:solidFill>
-              </a:rPr>
-              <a:t>Run FAO-56 advice for the zone</a:t>
-            </a:r>
-            <a:endParaRPr lang="en-US" sz="1100" dirty="0"/>
-          </a:p>
-        </p:txBody>
-      </p:sp>
-      <p:sp>
-        <p:nvSpPr>
-          <p:cNvPr id="24" name="Step 6"/>
-          <p:cNvSpPr txBox="1"/>
-          <p:nvPr/>
-        </p:nvSpPr>
-        <p:spPr>
-          <a:xfrm>
-            <a:off x="9098280" y="1234440"/>
-            <a:ext cx="384048" cy="384048"/>
-          </a:xfrm>
-          <a:prstGeom prst="ellipse">
-            <a:avLst/>
-          </a:prstGeom>
-          <a:solidFill>
-            <a:srgbClr val="1E88E5"/>
-          </a:solidFill>
-          <a:ln>
-            <a:solidFill>
-              <a:srgbClr val="1E88E5"/>
-            </a:solidFill>
-          </a:ln>
-        </p:spPr>
-        <p:txBody>
-          <a:bodyPr wrap="square" lIns="0" tIns="0" rIns="0" bIns="0" rtlCol="0" anchor="ctr"/>
-          <a:lstStyle/>
-          <a:p>
-            <a:pPr algn="ctr" indent="0" marL="0">
-              <a:buNone/>
-            </a:pPr>
-            <a:r>
-              <a:rPr lang="en-US" sz="1400" b="1" dirty="0">
-                <a:solidFill>
-                  <a:srgbClr val="FFFFFF"/>
-                </a:solidFill>
-              </a:rPr>
-              <a:t>6</a:t>
-            </a:r>
-            <a:endParaRPr lang="en-US" sz="1400" dirty="0"/>
-          </a:p>
-        </p:txBody>
-      </p:sp>
-      <p:sp>
-        <p:nvSpPr>
-          <p:cNvPr id="25" name="Shape 23"/>
-          <p:cNvSpPr/>
-          <p:nvPr/>
-        </p:nvSpPr>
-        <p:spPr>
-          <a:xfrm>
-            <a:off x="9537192" y="1426464"/>
-            <a:ext cx="1115568" cy="914"/>
-          </a:xfrm>
-          <a:prstGeom prst="line">
-            <a:avLst/>
-          </a:prstGeom>
-          <a:noFill/>
-          <a:ln w="19050">
-            <a:solidFill>
-              <a:srgbClr val="C9D6D9"/>
-            </a:solidFill>
-            <a:prstDash val="solid"/>
-            <a:tailEnd type="triangle"/>
-          </a:ln>
-        </p:spPr>
-      </p:sp>
-      <p:sp>
-        <p:nvSpPr>
           <p:cNvPr id="26" name="Text 24"/>
           <p:cNvSpPr txBox="1"/>
           <p:nvPr/>
@@ -3566,7 +3564,7 @@
                   <a:srgbClr val="0F2A36"/>
                 </a:solidFill>
               </a:rPr>
-              <a:t>Farmer's view</a:t>
+              <a:t>Run is recorded</a:t>
             </a:r>
             <a:endParaRPr lang="en-US" sz="1300" dirty="0"/>
           </a:p>
@@ -3581,7 +3579,7 @@
         <p:spPr>
           <a:xfrm>
             <a:off x="8549640" y="2157984"/>
-            <a:ext cx="1481328" cy="640080"/>
+            <a:ext cx="1481328" cy="548640"/>
           </a:xfrm>
           <a:prstGeom prst="rect">
             <a:avLst/>
@@ -3602,7 +3600,7 @@
                   <a:srgbClr val="5B6B73"/>
                 </a:solidFill>
               </a:rPr>
-              <a:t>Forecast, water report, Telegram</a:t>
+              <a:t>History: 5 min, Zone 2, manual</a:t>
             </a:r>
             <a:endParaRPr lang="en-US" sz="1100" dirty="0"/>
           </a:p>
@@ -3680,7 +3678,7 @@
                   <a:srgbClr val="0F2A36"/>
                 </a:solidFill>
               </a:rPr>
-              <a:t>Every action recorded</a:t>
+              <a:t>Admin follows up</a:t>
             </a:r>
             <a:endParaRPr lang="en-US" sz="1300" dirty="0"/>
           </a:p>
@@ -3695,7 +3693,7 @@
         <p:spPr>
           <a:xfrm>
             <a:off x="10158984" y="2157984"/>
-            <a:ext cx="1481328" cy="640080"/>
+            <a:ext cx="1481328" cy="548640"/>
           </a:xfrm>
           <a:prstGeom prst="rect">
             <a:avLst/>
@@ -3716,7 +3714,7 @@
                   <a:srgbClr val="5B6B73"/>
                 </a:solidFill>
               </a:rPr>
-              <a:t>Activity log</a:t>
+              <a:t>Alert, kits, reports, activity</a:t>
             </a:r>
             <a:endParaRPr lang="en-US" sz="1100" dirty="0"/>
           </a:p>
@@ -3724,7 +3722,7 @@
       </p:sp>
       <p:pic>
         <p:nvPicPr>
-          <p:cNvPr id="31" name="Admin — register farm wizard" descr="/home/user/AgroFlow/presentation/presentation-assets/ui/admin-register-farm-wizard.png">    </p:cNvPr>
+          <p:cNvPr id="31" name="Demo screen — Zone 2 readings and advice" descr="/home/user/AgroFlow/presentation/presentation-assets/ui/demo-m-zone2.png">    </p:cNvPr>
           <p:cNvPicPr>
             <a:picLocks noChangeAspect="1"/>
           </p:cNvPicPr>
@@ -3739,7 +3737,7 @@
         <p:spPr>
           <a:xfrm>
             <a:off x="685800" y="2926080"/>
-            <a:ext cx="3520440" cy="2200275"/>
+            <a:ext cx="1435129" cy="2971800"/>
           </a:xfrm>
           <a:prstGeom prst="rect">
             <a:avLst/>
@@ -3748,7 +3746,7 @@
       </p:pic>
       <p:pic>
         <p:nvPicPr>
-          <p:cNvPr id="32" name="Admin — kits" descr="/home/user/AgroFlow/presentation/presentation-assets/ui/admin-kits.png">    </p:cNvPr>
+          <p:cNvPr id="32" name="Demo screen — Manual run sent" descr="/home/user/AgroFlow/presentation/presentation-assets/ui/demo-m-zone2-sent.png">    </p:cNvPr>
           <p:cNvPicPr>
             <a:picLocks noChangeAspect="1"/>
           </p:cNvPicPr>
@@ -3762,8 +3760,8 @@
         </p:blipFill>
         <p:spPr>
           <a:xfrm>
-            <a:off x="4389120" y="2926080"/>
-            <a:ext cx="3520440" cy="2200275"/>
+            <a:off x="2377440" y="2926080"/>
+            <a:ext cx="1435129" cy="2971800"/>
           </a:xfrm>
           <a:prstGeom prst="rect">
             <a:avLst/>
@@ -3772,7 +3770,7 @@
       </p:pic>
       <p:pic>
         <p:nvPicPr>
-          <p:cNvPr id="33" name="Farmer app — reports" descr="/home/user/AgroFlow/presentation/presentation-assets/ui/mobile-reports.png">    </p:cNvPr>
+          <p:cNvPr id="33" name="Demo screen — Run recorded in History" descr="/home/user/AgroFlow/presentation/presentation-assets/ui/demo-m-history.png">    </p:cNvPr>
           <p:cNvPicPr>
             <a:picLocks noChangeAspect="1"/>
           </p:cNvPicPr>
@@ -3786,8 +3784,8 @@
         </p:blipFill>
         <p:spPr>
           <a:xfrm>
-            <a:off x="8229600" y="2834640"/>
-            <a:ext cx="1110257" cy="2331720"/>
+            <a:off x="4069080" y="2926080"/>
+            <a:ext cx="1435129" cy="2971800"/>
           </a:xfrm>
           <a:prstGeom prst="rect">
             <a:avLst/>
@@ -3796,18 +3794,54 @@
       </p:pic>
       <p:sp>
         <p:nvSpPr>
-          <p:cNvPr id="34" name="Validation example"/>
+          <p:cNvPr id="34" name="Text 29"/>
+          <p:cNvSpPr txBox="1"/>
+          <p:nvPr/>
+        </p:nvSpPr>
+        <p:spPr>
+          <a:xfrm>
+            <a:off x="685800" y="5989320"/>
+            <a:ext cx="4937760" cy="274320"/>
+          </a:xfrm>
+          <a:prstGeom prst="rect">
+            <a:avLst/>
+          </a:prstGeom>
+          <a:noFill/>
+          <a:ln/>
+        </p:spPr>
+        <p:txBody>
+          <a:bodyPr wrap="square" lIns="0" tIns="0" rIns="0" bIns="0" rtlCol="0" anchor="t"/>
+          <a:lstStyle/>
+          <a:p>
+            <a:pPr indent="0" marL="0">
+              <a:buNone/>
+            </a:pPr>
+            <a:r>
+              <a:rPr lang="en-US" sz="1000" i="1" dirty="0">
+                <a:solidFill>
+                  <a:srgbClr val="5B6B73"/>
+                </a:solidFill>
+              </a:rPr>
+              <a:t>Screens from our system demo: real app, illustrative demo data</a:t>
+            </a:r>
+            <a:endParaRPr lang="en-US" sz="1000" dirty="0"/>
+          </a:p>
+        </p:txBody>
+      </p:sp>
+      <p:sp>
+        <p:nvSpPr>
+          <p:cNvPr id="35" name="Validation example"/>
           <p:cNvSpPr/>
           <p:nvPr/>
         </p:nvSpPr>
         <p:spPr>
           <a:xfrm>
-            <a:off x="9509760" y="2880360"/>
-            <a:ext cx="2148840" cy="2286000"/>
+            <a:off x="5897880" y="2971800"/>
+            <a:ext cx="2743200" cy="1874520"/>
           </a:xfrm>
           <a:prstGeom prst="roundRect">
             <a:avLst>
-              <a:gd name="adj" fmla="val 5106"/>
+              <a:gd name="adj" fmla="val 5854"/>
             </a:avLst>
           </a:prstGeom>
           <a:solidFill>
@@ -3830,14 +3864,14 @@
       </p:sp>
       <p:sp>
         <p:nvSpPr>
-          <p:cNvPr id="35" name="Text 30"/>
-          <p:cNvSpPr txBox="1"/>
-          <p:nvPr/>
-        </p:nvSpPr>
-        <p:spPr>
-          <a:xfrm>
-            <a:off x="9646920" y="2971800"/>
-            <a:ext cx="1920240" cy="2103120"/>
+          <p:cNvPr id="36" name="Text 31"/>
+          <p:cNvSpPr txBox="1"/>
+          <p:nvPr/>
+        </p:nvSpPr>
+        <p:spPr>
+          <a:xfrm>
+            <a:off x="6035040" y="3063240"/>
+            <a:ext cx="2468880" cy="1691640"/>
           </a:xfrm>
           <a:prstGeom prst="rect">
             <a:avLst/>
@@ -3858,7 +3892,7 @@
                   <a:srgbClr val="7A5300"/>
                 </a:solidFill>
               </a:rPr>
-              <a:t>VALIDATION WE'LL SHOW</a:t>
+              <a:t>VALIDATION IN THE DEMO</a:t>
             </a:r>
             <a:endParaRPr lang="en-US" sz="1200" dirty="0"/>
           </a:p>
@@ -3872,7 +3906,7 @@
                   <a:srgbClr val="0F2A36"/>
                 </a:solidFill>
               </a:rPr>
-              <a:t>Farm name cleared on Review</a:t>
+              <a:t>Farmer types 90 minutes</a:t>
             </a:r>
             <a:endParaRPr lang="en-US" sz="1200" dirty="0"/>
           </a:p>
@@ -3895,55 +3929,115 @@
               <a:buNone/>
             </a:pPr>
             <a:r>
+              <a:rPr lang="en-US" sz="1200" i="1" dirty="0">
+                <a:solidFill>
+                  <a:srgbClr val="0F2A36"/>
+                </a:solidFill>
+              </a:rPr>
+              <a:t>“Enter a duration between 1 and 60 minutes.”</a:t>
+            </a:r>
+            <a:endParaRPr lang="en-US" sz="1200" dirty="0"/>
+          </a:p>
+          <a:p>
+            <a:pPr algn="ctr" indent="0" marL="0">
+              <a:buNone/>
+            </a:pPr>
+            <a:r>
               <a:rPr lang="en-US" sz="1200" dirty="0">
                 <a:solidFill>
+                  <a:srgbClr val="7A5300"/>
+                </a:solidFill>
+              </a:rPr>
+              <a:t>↓</a:t>
+            </a:r>
+            <a:endParaRPr lang="en-US" sz="1200" dirty="0"/>
+          </a:p>
+          <a:p>
+            <a:pPr algn="ctr" indent="0" marL="0">
+              <a:buNone/>
+            </a:pPr>
+            <a:r>
+              <a:rPr lang="en-US" sz="1200" dirty="0">
+                <a:solidFill>
                   <a:srgbClr val="0F2A36"/>
                 </a:solidFill>
               </a:rPr>
-              <a:t>Wizard jumps back to the step that is wrong</a:t>
+              <a:t>Corrected to 5 → confirmed → sent</a:t>
             </a:r>
             <a:endParaRPr lang="en-US" sz="1200" dirty="0"/>
           </a:p>
+        </p:txBody>
+      </p:sp>
+      <p:pic>
+        <p:nvPicPr>
+          <p:cNvPr id="37" name="Demo screen — admin kits" descr="/home/user/AgroFlow/presentation/presentation-assets/ui/demo-a-kits.png">    </p:cNvPr>
+          <p:cNvPicPr>
+            <a:picLocks noChangeAspect="1"/>
+          </p:cNvPicPr>
+          <p:nvPr/>
+        </p:nvPicPr>
+        <p:blipFill>
+          <a:blip r:embed="rId4"/>
+          <a:stretch>
+            <a:fillRect/>
+          </a:stretch>
+        </p:blipFill>
+        <p:spPr>
+          <a:xfrm>
+            <a:off x="8869680" y="2971800"/>
+            <a:ext cx="2788920" cy="1568768"/>
+          </a:xfrm>
+          <a:prstGeom prst="rect">
+            <a:avLst/>
+          </a:prstGeom>
+        </p:spPr>
+      </p:pic>
+      <p:sp>
+        <p:nvSpPr>
+          <p:cNvPr id="38" name="Text 32"/>
+          <p:cNvSpPr txBox="1"/>
+          <p:nvPr/>
+        </p:nvSpPr>
+        <p:spPr>
+          <a:xfrm>
+            <a:off x="8869680" y="4586288"/>
+            <a:ext cx="2788920" cy="274320"/>
+          </a:xfrm>
+          <a:prstGeom prst="rect">
+            <a:avLst/>
+          </a:prstGeom>
+          <a:noFill/>
+          <a:ln/>
+        </p:spPr>
+        <p:txBody>
+          <a:bodyPr wrap="square" lIns="0" tIns="0" rIns="0" bIns="0" rtlCol="0" anchor="t"/>
+          <a:lstStyle/>
           <a:p>
             <a:pPr algn="ctr" indent="0" marL="0">
               <a:buNone/>
             </a:pPr>
             <a:r>
-              <a:rPr lang="en-US" sz="1200" dirty="0">
-                <a:solidFill>
-                  <a:srgbClr val="7A5300"/>
-                </a:solidFill>
-              </a:rPr>
-              <a:t>↓</a:t>
-            </a:r>
-            <a:endParaRPr lang="en-US" sz="1200" dirty="0"/>
-          </a:p>
-          <a:p>
-            <a:pPr algn="ctr" indent="0" marL="0">
-              <a:buNone/>
-            </a:pPr>
-            <a:r>
-              <a:rPr lang="en-US" sz="1200" dirty="0">
-                <a:solidFill>
-                  <a:srgbClr val="0F2A36"/>
-                </a:solidFill>
-              </a:rPr>
-              <a:t>Corrected → farm registered</a:t>
-            </a:r>
-            <a:endParaRPr lang="en-US" sz="1200" dirty="0"/>
-          </a:p>
-        </p:txBody>
-      </p:sp>
-      <p:sp>
-        <p:nvSpPr>
-          <p:cNvPr id="36" name="Text 31"/>
-          <p:cNvSpPr txBox="1"/>
-          <p:nvPr/>
-        </p:nvSpPr>
-        <p:spPr>
-          <a:xfrm>
-            <a:off x="502920" y="5440680"/>
-            <a:ext cx="8778240" cy="594360"/>
+              <a:rPr lang="en-US" sz="1000" i="1" dirty="0">
+                <a:solidFill>
+                  <a:srgbClr val="5B6B73"/>
+                </a:solidFill>
+              </a:rPr>
+              <a:t>Admin console · Kits (demo data)</a:t>
+            </a:r>
+            <a:endParaRPr lang="en-US" sz="1000" dirty="0"/>
+          </a:p>
+        </p:txBody>
+      </p:sp>
+      <p:sp>
+        <p:nvSpPr>
+          <p:cNvPr id="39" name="Text 33"/>
+          <p:cNvSpPr txBox="1"/>
+          <p:nvPr/>
+        </p:nvSpPr>
+        <p:spPr>
+          <a:xfrm>
+            <a:off x="5897880" y="5349240"/>
+            <a:ext cx="5760720" cy="594360"/>
           </a:xfrm>
           <a:prstGeom prst="rect">
             <a:avLst/>

</xml_diff>